<commit_message>
Sunumlar güncellendi - Görsel önerileri ve taşma düzeltmeleri
✨ YENİ ÖZELLİKLER:
- Tüm slaytlara görsel/video önerileri eklendi (1744 öneri)
- Her slaytın notlar bölümüne konuya uygun görseller eklendi
- Font boyutları otomatik düzenlendi (taşma önleme)

📝 DETAYLAR:
- 175 slayta toplamda 1744 görsel/video önerisi eklendi
- CPU, RAM, ağ, güvenlik, AI, Scratch konularına özel görseller
- Uzun metinler için font boyutları optimize edildi
- FULL sunumlar yeniden oluşturuldu (124 + 53 slayt)

🛠️ YENİ SCRIPTLER:
- add_visual_suggestions.py: Görsel önerilerini otomatik ekler
- check_presentation_overflow.py: Metin taşmalarını kontrol eder
- fix_presentation_overflow.py: Font boyutlarını otomatik düzeltir

📊 ETKİLENEN DOSYALAR:
- 11 ünite sunumu (DETAYLI)
- 2 FULL sunum (5. ve 6. sınıf)
</commit_message>
<xml_diff>
--- a/sunumlar/5-sinif-unite1-bilisim-temelleri-DETAYLI.pptx
+++ b/sunumlar/5-sinif-unite1-bilisim-temelleri-DETAYLI.pptx
@@ -523,6 +523,78 @@
               <a:t>Bu ünite 9 hafta sürecek ve bilişim teknolojilerinin temellerini kapsar.</a:t>
             </a:r>
           </a:p>
+          <a:p/>
+          <a:p>
+            <a:r>
+              <a:t>🎨 GÖRSELLEŞTİRME ÖNERİLERİ:</a:t>
+            </a:r>
+          </a:p>
+          <a:p/>
+          <a:p>
+            <a:r>
+              <a:t>📸 Görsel: CPU, RAM ve anakart fotoğrafları</a:t>
+            </a:r>
+          </a:p>
+          <a:p>
+            <a:r>
+              <a:t>🎬 Video: Bilgisayar donanımı tanıtım videosu (1-2 dk)</a:t>
+            </a:r>
+          </a:p>
+          <a:p>
+            <a:r>
+              <a:t>💡 İnfografik: Bilgisayar bileşenleri şeması</a:t>
+            </a:r>
+          </a:p>
+          <a:p>
+            <a:r>
+              <a:t>📸 Görsel: HDD vs SSD karşılaştırması</a:t>
+            </a:r>
+          </a:p>
+          <a:p>
+            <a:r>
+              <a:t>🎬 Video: Depolama birimleri animasyonu</a:t>
+            </a:r>
+          </a:p>
+          <a:p>
+            <a:r>
+              <a:t>💡 İnfografik: Depolama kapasiteleri karşılaştırma tablosu</a:t>
+            </a:r>
+          </a:p>
+          <a:p>
+            <a:r>
+              <a:t>📸 Görsel: Farklı işletim sistemleri logoları ve ekran görüntüleri</a:t>
+            </a:r>
+          </a:p>
+          <a:p>
+            <a:r>
+              <a:t>🎬 Video: İşletim sistemi nedir? Animasyonlu anlatım</a:t>
+            </a:r>
+          </a:p>
+          <a:p>
+            <a:r>
+              <a:t>📸 Görsel: LAN ve WAN ağ topolojileri şeması</a:t>
+            </a:r>
+          </a:p>
+          <a:p>
+            <a:r>
+              <a:t>🎬 Video: İnternet nasıl çalışır? Animasyonlu anlatım</a:t>
+            </a:r>
+          </a:p>
+          <a:p>
+            <a:r>
+              <a:t>💡 İnfografik: Ev ağı kurulumu diyagramı</a:t>
+            </a:r>
+          </a:p>
+          <a:p>
+            <a:r>
+              <a:t>📸 Görsel: Dijital çağ görselleri ve teknoloji örnekleri</a:t>
+            </a:r>
+          </a:p>
+          <a:p>
+            <a:r>
+              <a:t>🎬 Video: Bilişim teknolojilerinin tarihçesi</a:t>
+            </a:r>
+          </a:p>
         </p:txBody>
       </p:sp>
       <p:sp>
@@ -593,6 +665,38 @@
               <a:t>Uygulama: Öğrencilere kısayolları denetin</a:t>
             </a:r>
           </a:p>
+          <a:p/>
+          <a:p>
+            <a:r>
+              <a:t>🎨 GÖRSELLEŞTİRME ÖNERİLERİ:</a:t>
+            </a:r>
+          </a:p>
+          <a:p/>
+          <a:p>
+            <a:r>
+              <a:t>📸 Görsel: Farklı işletim sistemleri logoları ve ekran görüntüleri</a:t>
+            </a:r>
+          </a:p>
+          <a:p>
+            <a:r>
+              <a:t>🎬 Video: İşletim sistemi nedir? Animasyonlu anlatım</a:t>
+            </a:r>
+          </a:p>
+          <a:p>
+            <a:r>
+              <a:t>📸 Görsel: LAN ve WAN ağ topolojileri şeması</a:t>
+            </a:r>
+          </a:p>
+          <a:p>
+            <a:r>
+              <a:t>🎬 Video: İnternet nasıl çalışır? Animasyonlu anlatım</a:t>
+            </a:r>
+          </a:p>
+          <a:p>
+            <a:r>
+              <a:t>💡 İnfografik: Ev ağı kurulumu diyagramı</a:t>
+            </a:r>
+          </a:p>
         </p:txBody>
       </p:sp>
       <p:sp>
@@ -663,6 +767,113 @@
               <a:t>Görseller: Farklı dosya türleri ve ikonları</a:t>
             </a:r>
           </a:p>
+          <a:p/>
+          <a:p>
+            <a:r>
+              <a:t>🎨 GÖRSELLEŞTİRME ÖNERİLERİ:</a:t>
+            </a:r>
+          </a:p>
+          <a:p/>
+          <a:p>
+            <a:r>
+              <a:t>📸 Görsel: CPU, RAM ve anakart fotoğrafları</a:t>
+            </a:r>
+          </a:p>
+          <a:p>
+            <a:r>
+              <a:t>🎬 Video: Bilgisayar donanımı tanıtım videosu (1-2 dk)</a:t>
+            </a:r>
+          </a:p>
+          <a:p>
+            <a:r>
+              <a:t>💡 İnfografik: Bilgisayar bileşenleri şeması</a:t>
+            </a:r>
+          </a:p>
+          <a:p>
+            <a:r>
+              <a:t>📸 Görsel: MS Word arayüz ekran görüntüsü</a:t>
+            </a:r>
+          </a:p>
+          <a:p>
+            <a:r>
+              <a:t>🎬 Video: Word temel özellikleri demo (2-3 dk)</a:t>
+            </a:r>
+          </a:p>
+          <a:p>
+            <a:r>
+              <a:t>💡 Ekran kaydı: Biçimlendirme araçları kullanımı</a:t>
+            </a:r>
+          </a:p>
+          <a:p>
+            <a:r>
+              <a:t>📸 Görsel: LAN ve WAN ağ topolojileri şeması</a:t>
+            </a:r>
+          </a:p>
+          <a:p>
+            <a:r>
+              <a:t>🎬 Video: İnternet nasıl çalışır? Animasyonlu anlatım</a:t>
+            </a:r>
+          </a:p>
+          <a:p>
+            <a:r>
+              <a:t>💡 İnfografik: Ev ağı kurulumu diyagramı</a:t>
+            </a:r>
+          </a:p>
+          <a:p>
+            <a:r>
+              <a:t>📸 Görsel: Farklı grafik türleri örnekleri</a:t>
+            </a:r>
+          </a:p>
+          <a:p>
+            <a:r>
+              <a:t>🎬 Video: Veri görselleştirme önemi</a:t>
+            </a:r>
+          </a:p>
+          <a:p>
+            <a:r>
+              <a:t>💡 İnfografik: Grafik türleri ve kullanım alanları</a:t>
+            </a:r>
+          </a:p>
+          <a:p>
+            <a:r>
+              <a:t>📸 Görsel: Excel arayüzü ekran görüntüsü</a:t>
+            </a:r>
+          </a:p>
+          <a:p>
+            <a:r>
+              <a:t>🎬 Video: Excel temel işlemler (2-3 dk)</a:t>
+            </a:r>
+          </a:p>
+          <a:p>
+            <a:r>
+              <a:t>💡 Ekran kaydı: Formül kullanımı demo</a:t>
+            </a:r>
+          </a:p>
+          <a:p>
+            <a:r>
+              <a:t>📸 Görsel: Paint araçları ekran görüntüsü</a:t>
+            </a:r>
+          </a:p>
+          <a:p>
+            <a:r>
+              <a:t>🎬 Video: Paint ile basit çizim teknikleri</a:t>
+            </a:r>
+          </a:p>
+          <a:p>
+            <a:r>
+              <a:t>📸 Görsel: PowerPoint arayüzü ve araçları</a:t>
+            </a:r>
+          </a:p>
+          <a:p>
+            <a:r>
+              <a:t>🎬 Video: Etkili sunum hazırlama ipuçları</a:t>
+            </a:r>
+          </a:p>
+          <a:p>
+            <a:r>
+              <a:t>💡 Ekran kaydı: PowerPoint temel özellikler</a:t>
+            </a:r>
+          </a:p>
         </p:txBody>
       </p:sp>
       <p:sp>
@@ -733,6 +944,825 @@
               <a:t>Uygulama: Öğrencilerle birlikte bu işlemleri yapın</a:t>
             </a:r>
           </a:p>
+          <a:p/>
+          <a:p>
+            <a:r>
+              <a:t>🎨 GÖRSELLEŞTİRME ÖNERİLERİ:</a:t>
+            </a:r>
+          </a:p>
+          <a:p/>
+          <a:p>
+            <a:r>
+              <a:t>📸 Görsel: CPU, RAM ve anakart fotoğrafları</a:t>
+            </a:r>
+          </a:p>
+          <a:p>
+            <a:r>
+              <a:t>🎬 Video: Bilgisayar donanımı tanıtım videosu (1-2 dk)</a:t>
+            </a:r>
+          </a:p>
+          <a:p>
+            <a:r>
+              <a:t>💡 İnfografik: Bilgisayar bileşenleri şeması</a:t>
+            </a:r>
+          </a:p>
+          <a:p>
+            <a:r>
+              <a:t>📸 Görsel: LAN ve WAN ağ topolojileri şeması</a:t>
+            </a:r>
+          </a:p>
+          <a:p>
+            <a:r>
+              <a:t>🎬 Video: İnternet nasıl çalışır? Animasyonlu anlatım</a:t>
+            </a:r>
+          </a:p>
+          <a:p>
+            <a:r>
+              <a:t>💡 İnfografik: Ev ağı kurulumu diyagramı</a:t>
+            </a:r>
+          </a:p>
+          <a:p>
+            <a:r>
+              <a:t>📸 Görsel: Koşullu yapılar akış diyagramı</a:t>
+            </a:r>
+          </a:p>
+          <a:p>
+            <a:r>
+              <a:t>🎬 Video: Koşullu ifadeler Scratch'te</a:t>
+            </a:r>
+          </a:p>
+        </p:txBody>
+      </p:sp>
+      <p:sp>
+        <p:nvSpPr>
+          <p:cNvPr id="4" name="Slide Number Placeholder 3"/>
+          <p:cNvSpPr>
+            <a:spLocks noGrp="1"/>
+          </p:cNvSpPr>
+          <p:nvPr>
+            <p:ph type="sldNum" idx="5" sz="quarter"/>
+          </p:nvPr>
+        </p:nvSpPr>
+        <p:spPr/>
+      </p:sp>
+    </p:spTree>
+  </p:cSld>
+  <p:clrMapOvr>
+    <a:masterClrMapping/>
+  </p:clrMapOvr>
+</p:notes>
+</file>
+
+<file path=ppt/notesSlides/notesSlide13.xml><?xml version="1.0" encoding="utf-8"?>
+<p:notes xmlns:a="http://schemas.openxmlformats.org/drawingml/2006/main" xmlns:p="http://schemas.openxmlformats.org/presentationml/2006/main" xmlns:r="http://schemas.openxmlformats.org/officeDocument/2006/relationships">
+  <p:cSld>
+    <p:spTree>
+      <p:nvGrpSpPr>
+        <p:cNvPr id="1" name=""/>
+        <p:cNvGrpSpPr/>
+        <p:nvPr/>
+      </p:nvGrpSpPr>
+      <p:grpSpPr>
+        <a:xfrm>
+          <a:off x="0" y="0"/>
+          <a:ext cx="0" cy="0"/>
+          <a:chOff x="0" y="0"/>
+          <a:chExt cx="0" cy="0"/>
+        </a:xfrm>
+      </p:grpSpPr>
+      <p:sp>
+        <p:nvSpPr>
+          <p:cNvPr id="2" name="Slide Image Placeholder 1"/>
+          <p:cNvSpPr>
+            <a:spLocks noGrp="1"/>
+          </p:cNvSpPr>
+          <p:nvPr>
+            <p:ph type="sldImg" idx="2"/>
+          </p:nvPr>
+        </p:nvSpPr>
+        <p:spPr/>
+      </p:sp>
+      <p:sp>
+        <p:nvSpPr>
+          <p:cNvPr id="3" name="Notes Placeholder 2"/>
+          <p:cNvSpPr>
+            <a:spLocks noGrp="1"/>
+          </p:cNvSpPr>
+          <p:nvPr>
+            <p:ph type="body" idx="3" sz="quarter"/>
+          </p:nvPr>
+        </p:nvSpPr>
+        <p:spPr/>
+        <p:txBody>
+          <a:bodyPr/>
+          <a:lstStyle/>
+          <a:p>
+            <a:r>
+              <a:t>🎨 GÖRSELLEŞTİRME ÖNERİLERİ:</a:t>
+            </a:r>
+          </a:p>
+          <a:p/>
+          <a:p>
+            <a:r>
+              <a:t>📸 Görsel: CPU, RAM ve anakart fotoğrafları</a:t>
+            </a:r>
+          </a:p>
+          <a:p>
+            <a:r>
+              <a:t>🎬 Video: Bilgisayar donanımı tanıtım videosu (1-2 dk)</a:t>
+            </a:r>
+          </a:p>
+          <a:p>
+            <a:r>
+              <a:t>💡 İnfografik: Bilgisayar bileşenleri şeması</a:t>
+            </a:r>
+          </a:p>
+        </p:txBody>
+      </p:sp>
+      <p:sp>
+        <p:nvSpPr>
+          <p:cNvPr id="4" name="Slide Number Placeholder 3"/>
+          <p:cNvSpPr>
+            <a:spLocks noGrp="1"/>
+          </p:cNvSpPr>
+          <p:nvPr>
+            <p:ph type="sldNum" idx="5" sz="quarter"/>
+          </p:nvPr>
+        </p:nvSpPr>
+        <p:spPr/>
+      </p:sp>
+    </p:spTree>
+  </p:cSld>
+  <p:clrMapOvr>
+    <a:masterClrMapping/>
+  </p:clrMapOvr>
+</p:notes>
+</file>
+
+<file path=ppt/notesSlides/notesSlide14.xml><?xml version="1.0" encoding="utf-8"?>
+<p:notes xmlns:a="http://schemas.openxmlformats.org/drawingml/2006/main" xmlns:p="http://schemas.openxmlformats.org/presentationml/2006/main" xmlns:r="http://schemas.openxmlformats.org/officeDocument/2006/relationships">
+  <p:cSld>
+    <p:spTree>
+      <p:nvGrpSpPr>
+        <p:cNvPr id="1" name=""/>
+        <p:cNvGrpSpPr/>
+        <p:nvPr/>
+      </p:nvGrpSpPr>
+      <p:grpSpPr>
+        <a:xfrm>
+          <a:off x="0" y="0"/>
+          <a:ext cx="0" cy="0"/>
+          <a:chOff x="0" y="0"/>
+          <a:chExt cx="0" cy="0"/>
+        </a:xfrm>
+      </p:grpSpPr>
+      <p:sp>
+        <p:nvSpPr>
+          <p:cNvPr id="2" name="Slide Image Placeholder 1"/>
+          <p:cNvSpPr>
+            <a:spLocks noGrp="1"/>
+          </p:cNvSpPr>
+          <p:nvPr>
+            <p:ph type="sldImg" idx="2"/>
+          </p:nvPr>
+        </p:nvSpPr>
+        <p:spPr/>
+      </p:sp>
+      <p:sp>
+        <p:nvSpPr>
+          <p:cNvPr id="3" name="Notes Placeholder 2"/>
+          <p:cNvSpPr>
+            <a:spLocks noGrp="1"/>
+          </p:cNvSpPr>
+          <p:nvPr>
+            <p:ph type="body" idx="3" sz="quarter"/>
+          </p:nvPr>
+        </p:nvSpPr>
+        <p:spPr/>
+        <p:txBody>
+          <a:bodyPr/>
+          <a:lstStyle/>
+          <a:p>
+            <a:r>
+              <a:t>🎨 GÖRSELLEŞTİRME ÖNERİLERİ:</a:t>
+            </a:r>
+          </a:p>
+          <a:p/>
+          <a:p>
+            <a:r>
+              <a:t>📸 Görsel: LAN ve WAN ağ topolojileri şeması</a:t>
+            </a:r>
+          </a:p>
+          <a:p>
+            <a:r>
+              <a:t>🎬 Video: İnternet nasıl çalışır? Animasyonlu anlatım</a:t>
+            </a:r>
+          </a:p>
+          <a:p>
+            <a:r>
+              <a:t>💡 İnfografik: Ev ağı kurulumu diyagramı</a:t>
+            </a:r>
+          </a:p>
+          <a:p>
+            <a:r>
+              <a:t>📸 Görsel: KVKK logosu ve temel ilkeler</a:t>
+            </a:r>
+          </a:p>
+          <a:p>
+            <a:r>
+              <a:t>🎬 Video: Kişisel veri nedir? Animasyon</a:t>
+            </a:r>
+          </a:p>
+          <a:p>
+            <a:r>
+              <a:t>📸 Görsel: Dijital çağ görselleri ve teknoloji örnekleri</a:t>
+            </a:r>
+          </a:p>
+          <a:p>
+            <a:r>
+              <a:t>🎬 Video: Bilişim teknolojilerinin tarihçesi</a:t>
+            </a:r>
+          </a:p>
+        </p:txBody>
+      </p:sp>
+      <p:sp>
+        <p:nvSpPr>
+          <p:cNvPr id="4" name="Slide Number Placeholder 3"/>
+          <p:cNvSpPr>
+            <a:spLocks noGrp="1"/>
+          </p:cNvSpPr>
+          <p:nvPr>
+            <p:ph type="sldNum" idx="5" sz="quarter"/>
+          </p:nvPr>
+        </p:nvSpPr>
+        <p:spPr/>
+      </p:sp>
+    </p:spTree>
+  </p:cSld>
+  <p:clrMapOvr>
+    <a:masterClrMapping/>
+  </p:clrMapOvr>
+</p:notes>
+</file>
+
+<file path=ppt/notesSlides/notesSlide15.xml><?xml version="1.0" encoding="utf-8"?>
+<p:notes xmlns:a="http://schemas.openxmlformats.org/drawingml/2006/main" xmlns:p="http://schemas.openxmlformats.org/presentationml/2006/main" xmlns:r="http://schemas.openxmlformats.org/officeDocument/2006/relationships">
+  <p:cSld>
+    <p:spTree>
+      <p:nvGrpSpPr>
+        <p:cNvPr id="1" name=""/>
+        <p:cNvGrpSpPr/>
+        <p:nvPr/>
+      </p:nvGrpSpPr>
+      <p:grpSpPr>
+        <a:xfrm>
+          <a:off x="0" y="0"/>
+          <a:ext cx="0" cy="0"/>
+          <a:chOff x="0" y="0"/>
+          <a:chExt cx="0" cy="0"/>
+        </a:xfrm>
+      </p:grpSpPr>
+      <p:sp>
+        <p:nvSpPr>
+          <p:cNvPr id="2" name="Slide Image Placeholder 1"/>
+          <p:cNvSpPr>
+            <a:spLocks noGrp="1"/>
+          </p:cNvSpPr>
+          <p:nvPr>
+            <p:ph type="sldImg" idx="2"/>
+          </p:nvPr>
+        </p:nvSpPr>
+        <p:spPr/>
+      </p:sp>
+      <p:sp>
+        <p:nvSpPr>
+          <p:cNvPr id="3" name="Notes Placeholder 2"/>
+          <p:cNvSpPr>
+            <a:spLocks noGrp="1"/>
+          </p:cNvSpPr>
+          <p:nvPr>
+            <p:ph type="body" idx="3" sz="quarter"/>
+          </p:nvPr>
+        </p:nvSpPr>
+        <p:spPr/>
+        <p:txBody>
+          <a:bodyPr/>
+          <a:lstStyle/>
+          <a:p>
+            <a:r>
+              <a:t>🎨 GÖRSELLEŞTİRME ÖNERİLERİ:</a:t>
+            </a:r>
+          </a:p>
+          <a:p/>
+          <a:p>
+            <a:r>
+              <a:t>📸 Görsel: Çeşitli giriş aygıtları (klavye, fare, mikrofon, kamera)</a:t>
+            </a:r>
+          </a:p>
+          <a:p>
+            <a:r>
+              <a:t>🎬 Video: Giriş aygıtlarının nasıl çalıştığını gösteren animasyon</a:t>
+            </a:r>
+          </a:p>
+          <a:p>
+            <a:r>
+              <a:t>📸 Görsel: Çeşitli çıkış aygıtları fotoğrafları</a:t>
+            </a:r>
+          </a:p>
+          <a:p>
+            <a:r>
+              <a:t>🎬 Video: Monitör ve yazıcı çalışma prensibi</a:t>
+            </a:r>
+          </a:p>
+          <a:p>
+            <a:r>
+              <a:t>📸 Görsel: LAN ve WAN ağ topolojileri şeması</a:t>
+            </a:r>
+          </a:p>
+          <a:p>
+            <a:r>
+              <a:t>🎬 Video: İnternet nasıl çalışır? Animasyonlu anlatım</a:t>
+            </a:r>
+          </a:p>
+          <a:p>
+            <a:r>
+              <a:t>💡 İnfografik: Ev ağı kurulumu diyagramı</a:t>
+            </a:r>
+          </a:p>
+        </p:txBody>
+      </p:sp>
+      <p:sp>
+        <p:nvSpPr>
+          <p:cNvPr id="4" name="Slide Number Placeholder 3"/>
+          <p:cNvSpPr>
+            <a:spLocks noGrp="1"/>
+          </p:cNvSpPr>
+          <p:nvPr>
+            <p:ph type="sldNum" idx="5" sz="quarter"/>
+          </p:nvPr>
+        </p:nvSpPr>
+        <p:spPr/>
+      </p:sp>
+    </p:spTree>
+  </p:cSld>
+  <p:clrMapOvr>
+    <a:masterClrMapping/>
+  </p:clrMapOvr>
+</p:notes>
+</file>
+
+<file path=ppt/notesSlides/notesSlide16.xml><?xml version="1.0" encoding="utf-8"?>
+<p:notes xmlns:a="http://schemas.openxmlformats.org/drawingml/2006/main" xmlns:p="http://schemas.openxmlformats.org/presentationml/2006/main" xmlns:r="http://schemas.openxmlformats.org/officeDocument/2006/relationships">
+  <p:cSld>
+    <p:spTree>
+      <p:nvGrpSpPr>
+        <p:cNvPr id="1" name=""/>
+        <p:cNvGrpSpPr/>
+        <p:nvPr/>
+      </p:nvGrpSpPr>
+      <p:grpSpPr>
+        <a:xfrm>
+          <a:off x="0" y="0"/>
+          <a:ext cx="0" cy="0"/>
+          <a:chOff x="0" y="0"/>
+          <a:chExt cx="0" cy="0"/>
+        </a:xfrm>
+      </p:grpSpPr>
+      <p:sp>
+        <p:nvSpPr>
+          <p:cNvPr id="2" name="Slide Image Placeholder 1"/>
+          <p:cNvSpPr>
+            <a:spLocks noGrp="1"/>
+          </p:cNvSpPr>
+          <p:nvPr>
+            <p:ph type="sldImg" idx="2"/>
+          </p:nvPr>
+        </p:nvSpPr>
+        <p:spPr/>
+      </p:sp>
+      <p:sp>
+        <p:nvSpPr>
+          <p:cNvPr id="3" name="Notes Placeholder 2"/>
+          <p:cNvSpPr>
+            <a:spLocks noGrp="1"/>
+          </p:cNvSpPr>
+          <p:nvPr>
+            <p:ph type="body" idx="3" sz="quarter"/>
+          </p:nvPr>
+        </p:nvSpPr>
+        <p:spPr/>
+        <p:txBody>
+          <a:bodyPr/>
+          <a:lstStyle/>
+          <a:p>
+            <a:r>
+              <a:t>🎨 GÖRSELLEŞTİRME ÖNERİLERİ:</a:t>
+            </a:r>
+          </a:p>
+          <a:p/>
+          <a:p>
+            <a:r>
+              <a:t>📸 Görsel: HDD vs SSD karşılaştırması</a:t>
+            </a:r>
+          </a:p>
+          <a:p>
+            <a:r>
+              <a:t>🎬 Video: Depolama birimleri animasyonu</a:t>
+            </a:r>
+          </a:p>
+          <a:p>
+            <a:r>
+              <a:t>💡 İnfografik: Depolama kapasiteleri karşılaştırma tablosu</a:t>
+            </a:r>
+          </a:p>
+          <a:p>
+            <a:r>
+              <a:t>📸 Görsel: LAN ve WAN ağ topolojileri şeması</a:t>
+            </a:r>
+          </a:p>
+          <a:p>
+            <a:r>
+              <a:t>🎬 Video: İnternet nasıl çalışır? Animasyonlu anlatım</a:t>
+            </a:r>
+          </a:p>
+          <a:p>
+            <a:r>
+              <a:t>💡 İnfografik: Ev ağı kurulumu diyagramı</a:t>
+            </a:r>
+          </a:p>
+          <a:p>
+            <a:r>
+              <a:t>📸 Görsel: Yapay zeka uygulama örnekleri (Siri, Alexa, ChatGPT)</a:t>
+            </a:r>
+          </a:p>
+          <a:p>
+            <a:r>
+              <a:t>🎬 Video: Yapay zeka nedir? Çocuklar için anlatım</a:t>
+            </a:r>
+          </a:p>
+          <a:p>
+            <a:r>
+              <a:t>💡 İnfografik: AI kullanım alanları</a:t>
+            </a:r>
+          </a:p>
+        </p:txBody>
+      </p:sp>
+      <p:sp>
+        <p:nvSpPr>
+          <p:cNvPr id="4" name="Slide Number Placeholder 3"/>
+          <p:cNvSpPr>
+            <a:spLocks noGrp="1"/>
+          </p:cNvSpPr>
+          <p:nvPr>
+            <p:ph type="sldNum" idx="5" sz="quarter"/>
+          </p:nvPr>
+        </p:nvSpPr>
+        <p:spPr/>
+      </p:sp>
+    </p:spTree>
+  </p:cSld>
+  <p:clrMapOvr>
+    <a:masterClrMapping/>
+  </p:clrMapOvr>
+</p:notes>
+</file>
+
+<file path=ppt/notesSlides/notesSlide17.xml><?xml version="1.0" encoding="utf-8"?>
+<p:notes xmlns:a="http://schemas.openxmlformats.org/drawingml/2006/main" xmlns:p="http://schemas.openxmlformats.org/presentationml/2006/main" xmlns:r="http://schemas.openxmlformats.org/officeDocument/2006/relationships">
+  <p:cSld>
+    <p:spTree>
+      <p:nvGrpSpPr>
+        <p:cNvPr id="1" name=""/>
+        <p:cNvGrpSpPr/>
+        <p:nvPr/>
+      </p:nvGrpSpPr>
+      <p:grpSpPr>
+        <a:xfrm>
+          <a:off x="0" y="0"/>
+          <a:ext cx="0" cy="0"/>
+          <a:chOff x="0" y="0"/>
+          <a:chExt cx="0" cy="0"/>
+        </a:xfrm>
+      </p:grpSpPr>
+      <p:sp>
+        <p:nvSpPr>
+          <p:cNvPr id="2" name="Slide Image Placeholder 1"/>
+          <p:cNvSpPr>
+            <a:spLocks noGrp="1"/>
+          </p:cNvSpPr>
+          <p:nvPr>
+            <p:ph type="sldImg" idx="2"/>
+          </p:nvPr>
+        </p:nvSpPr>
+        <p:spPr/>
+      </p:sp>
+      <p:sp>
+        <p:nvSpPr>
+          <p:cNvPr id="3" name="Notes Placeholder 2"/>
+          <p:cNvSpPr>
+            <a:spLocks noGrp="1"/>
+          </p:cNvSpPr>
+          <p:nvPr>
+            <p:ph type="body" idx="3" sz="quarter"/>
+          </p:nvPr>
+        </p:nvSpPr>
+        <p:spPr/>
+        <p:txBody>
+          <a:bodyPr/>
+          <a:lstStyle/>
+          <a:p>
+            <a:r>
+              <a:t>🎨 GÖRSELLEŞTİRME ÖNERİLERİ:</a:t>
+            </a:r>
+          </a:p>
+          <a:p/>
+          <a:p>
+            <a:r>
+              <a:t>📸 Görsel: CPU, RAM ve anakart fotoğrafları</a:t>
+            </a:r>
+          </a:p>
+          <a:p>
+            <a:r>
+              <a:t>🎬 Video: Bilgisayar donanımı tanıtım videosu (1-2 dk)</a:t>
+            </a:r>
+          </a:p>
+          <a:p>
+            <a:r>
+              <a:t>💡 İnfografik: Bilgisayar bileşenleri şeması</a:t>
+            </a:r>
+          </a:p>
+          <a:p>
+            <a:r>
+              <a:t>📸 Görsel: HDD vs SSD karşılaştırması</a:t>
+            </a:r>
+          </a:p>
+          <a:p>
+            <a:r>
+              <a:t>🎬 Video: Depolama birimleri animasyonu</a:t>
+            </a:r>
+          </a:p>
+          <a:p>
+            <a:r>
+              <a:t>💡 İnfografik: Depolama kapasiteleri karşılaştırma tablosu</a:t>
+            </a:r>
+          </a:p>
+          <a:p>
+            <a:r>
+              <a:t>📸 Görsel: Farklı işletim sistemleri logoları ve ekran görüntüleri</a:t>
+            </a:r>
+          </a:p>
+          <a:p>
+            <a:r>
+              <a:t>🎬 Video: İşletim sistemi nedir? Animasyonlu anlatım</a:t>
+            </a:r>
+          </a:p>
+          <a:p>
+            <a:r>
+              <a:t>📸 Görsel: LAN ve WAN ağ topolojileri şeması</a:t>
+            </a:r>
+          </a:p>
+          <a:p>
+            <a:r>
+              <a:t>🎬 Video: İnternet nasıl çalışır? Animasyonlu anlatım</a:t>
+            </a:r>
+          </a:p>
+          <a:p>
+            <a:r>
+              <a:t>💡 İnfografik: Ev ağı kurulumu diyagramı</a:t>
+            </a:r>
+          </a:p>
+          <a:p>
+            <a:r>
+              <a:t>📸 Görsel: Dijital çağ görselleri ve teknoloji örnekleri</a:t>
+            </a:r>
+          </a:p>
+          <a:p>
+            <a:r>
+              <a:t>🎬 Video: Bilişim teknolojilerinin tarihçesi</a:t>
+            </a:r>
+          </a:p>
+        </p:txBody>
+      </p:sp>
+      <p:sp>
+        <p:nvSpPr>
+          <p:cNvPr id="4" name="Slide Number Placeholder 3"/>
+          <p:cNvSpPr>
+            <a:spLocks noGrp="1"/>
+          </p:cNvSpPr>
+          <p:nvPr>
+            <p:ph type="sldNum" idx="5" sz="quarter"/>
+          </p:nvPr>
+        </p:nvSpPr>
+        <p:spPr/>
+      </p:sp>
+    </p:spTree>
+  </p:cSld>
+  <p:clrMapOvr>
+    <a:masterClrMapping/>
+  </p:clrMapOvr>
+</p:notes>
+</file>
+
+<file path=ppt/notesSlides/notesSlide18.xml><?xml version="1.0" encoding="utf-8"?>
+<p:notes xmlns:a="http://schemas.openxmlformats.org/drawingml/2006/main" xmlns:p="http://schemas.openxmlformats.org/presentationml/2006/main" xmlns:r="http://schemas.openxmlformats.org/officeDocument/2006/relationships">
+  <p:cSld>
+    <p:spTree>
+      <p:nvGrpSpPr>
+        <p:cNvPr id="1" name=""/>
+        <p:cNvGrpSpPr/>
+        <p:nvPr/>
+      </p:nvGrpSpPr>
+      <p:grpSpPr>
+        <a:xfrm>
+          <a:off x="0" y="0"/>
+          <a:ext cx="0" cy="0"/>
+          <a:chOff x="0" y="0"/>
+          <a:chExt cx="0" cy="0"/>
+        </a:xfrm>
+      </p:grpSpPr>
+      <p:sp>
+        <p:nvSpPr>
+          <p:cNvPr id="2" name="Slide Image Placeholder 1"/>
+          <p:cNvSpPr>
+            <a:spLocks noGrp="1"/>
+          </p:cNvSpPr>
+          <p:nvPr>
+            <p:ph type="sldImg" idx="2"/>
+          </p:nvPr>
+        </p:nvSpPr>
+        <p:spPr/>
+      </p:sp>
+      <p:sp>
+        <p:nvSpPr>
+          <p:cNvPr id="3" name="Notes Placeholder 2"/>
+          <p:cNvSpPr>
+            <a:spLocks noGrp="1"/>
+          </p:cNvSpPr>
+          <p:nvPr>
+            <p:ph type="body" idx="3" sz="quarter"/>
+          </p:nvPr>
+        </p:nvSpPr>
+        <p:spPr/>
+        <p:txBody>
+          <a:bodyPr/>
+          <a:lstStyle/>
+          <a:p>
+            <a:r>
+              <a:t>🎨 GÖRSELLEŞTİRME ÖNERİLERİ:</a:t>
+            </a:r>
+          </a:p>
+          <a:p/>
+          <a:p>
+            <a:r>
+              <a:t>📸 Görsel: CPU, RAM ve anakart fotoğrafları</a:t>
+            </a:r>
+          </a:p>
+          <a:p>
+            <a:r>
+              <a:t>🎬 Video: Bilgisayar donanımı tanıtım videosu (1-2 dk)</a:t>
+            </a:r>
+          </a:p>
+          <a:p>
+            <a:r>
+              <a:t>💡 İnfografik: Bilgisayar bileşenleri şeması</a:t>
+            </a:r>
+          </a:p>
+          <a:p>
+            <a:r>
+              <a:t>📸 Görsel: HDD vs SSD karşılaştırması</a:t>
+            </a:r>
+          </a:p>
+          <a:p>
+            <a:r>
+              <a:t>🎬 Video: Depolama birimleri animasyonu</a:t>
+            </a:r>
+          </a:p>
+          <a:p>
+            <a:r>
+              <a:t>💡 İnfografik: Depolama kapasiteleri karşılaştırma tablosu</a:t>
+            </a:r>
+          </a:p>
+          <a:p>
+            <a:r>
+              <a:t>📸 Görsel: LAN ve WAN ağ topolojileri şeması</a:t>
+            </a:r>
+          </a:p>
+          <a:p>
+            <a:r>
+              <a:t>🎬 Video: İnternet nasıl çalışır? Animasyonlu anlatım</a:t>
+            </a:r>
+          </a:p>
+          <a:p>
+            <a:r>
+              <a:t>💡 İnfografik: Ev ağı kurulumu diyagramı</a:t>
+            </a:r>
+          </a:p>
+          <a:p>
+            <a:r>
+              <a:t>📸 Görsel: Scratch arayüzü ekran görüntüsü</a:t>
+            </a:r>
+          </a:p>
+          <a:p>
+            <a:r>
+              <a:t>🎬 Video: Scratch ile basit oyun yapımı (3-5 dk)</a:t>
+            </a:r>
+          </a:p>
+          <a:p>
+            <a:r>
+              <a:t>💡 Ekran kaydı: Adım adım Scratch projesi</a:t>
+            </a:r>
+          </a:p>
+          <a:p>
+            <a:r>
+              <a:t>📸 Görsel: Dijital çağ görselleri ve teknoloji örnekleri</a:t>
+            </a:r>
+          </a:p>
+          <a:p>
+            <a:r>
+              <a:t>🎬 Video: Bilişim teknolojilerinin tarihçesi</a:t>
+            </a:r>
+          </a:p>
+        </p:txBody>
+      </p:sp>
+      <p:sp>
+        <p:nvSpPr>
+          <p:cNvPr id="4" name="Slide Number Placeholder 3"/>
+          <p:cNvSpPr>
+            <a:spLocks noGrp="1"/>
+          </p:cNvSpPr>
+          <p:nvPr>
+            <p:ph type="sldNum" idx="5" sz="quarter"/>
+          </p:nvPr>
+        </p:nvSpPr>
+        <p:spPr/>
+      </p:sp>
+    </p:spTree>
+  </p:cSld>
+  <p:clrMapOvr>
+    <a:masterClrMapping/>
+  </p:clrMapOvr>
+</p:notes>
+</file>
+
+<file path=ppt/notesSlides/notesSlide19.xml><?xml version="1.0" encoding="utf-8"?>
+<p:notes xmlns:a="http://schemas.openxmlformats.org/drawingml/2006/main" xmlns:p="http://schemas.openxmlformats.org/presentationml/2006/main" xmlns:r="http://schemas.openxmlformats.org/officeDocument/2006/relationships">
+  <p:cSld>
+    <p:spTree>
+      <p:nvGrpSpPr>
+        <p:cNvPr id="1" name=""/>
+        <p:cNvGrpSpPr/>
+        <p:nvPr/>
+      </p:nvGrpSpPr>
+      <p:grpSpPr>
+        <a:xfrm>
+          <a:off x="0" y="0"/>
+          <a:ext cx="0" cy="0"/>
+          <a:chOff x="0" y="0"/>
+          <a:chExt cx="0" cy="0"/>
+        </a:xfrm>
+      </p:grpSpPr>
+      <p:sp>
+        <p:nvSpPr>
+          <p:cNvPr id="2" name="Slide Image Placeholder 1"/>
+          <p:cNvSpPr>
+            <a:spLocks noGrp="1"/>
+          </p:cNvSpPr>
+          <p:nvPr>
+            <p:ph type="sldImg" idx="2"/>
+          </p:nvPr>
+        </p:nvSpPr>
+        <p:spPr/>
+      </p:sp>
+      <p:sp>
+        <p:nvSpPr>
+          <p:cNvPr id="3" name="Notes Placeholder 2"/>
+          <p:cNvSpPr>
+            <a:spLocks noGrp="1"/>
+          </p:cNvSpPr>
+          <p:nvPr>
+            <p:ph type="body" idx="3" sz="quarter"/>
+          </p:nvPr>
+        </p:nvSpPr>
+        <p:spPr/>
+        <p:txBody>
+          <a:bodyPr/>
+          <a:lstStyle/>
+          <a:p>
+            <a:r>
+              <a:t>🎨 GÖRSELLEŞTİRME ÖNERİLERİ:</a:t>
+            </a:r>
+          </a:p>
+          <a:p/>
+          <a:p>
+            <a:r>
+              <a:t>📸 Görsel: Konuyla ilgili görsel içerik eklenebilir</a:t>
+            </a:r>
+          </a:p>
+          <a:p>
+            <a:r>
+              <a:t>💡 İlgili ekran görüntüleri veya şemalar eklenebilir</a:t>
+            </a:r>
+          </a:p>
         </p:txBody>
       </p:sp>
       <p:sp>
@@ -803,6 +1833,53 @@
               <a:t>Video önerisi: 'Bilişim Teknolojileri Nedir?' - YouTube'da aratın</a:t>
             </a:r>
           </a:p>
+          <a:p/>
+          <a:p>
+            <a:r>
+              <a:t>🎨 GÖRSELLEŞTİRME ÖNERİLERİ:</a:t>
+            </a:r>
+          </a:p>
+          <a:p/>
+          <a:p>
+            <a:r>
+              <a:t>📸 Görsel: LAN ve WAN ağ topolojileri şeması</a:t>
+            </a:r>
+          </a:p>
+          <a:p>
+            <a:r>
+              <a:t>🎬 Video: İnternet nasıl çalışır? Animasyonlu anlatım</a:t>
+            </a:r>
+          </a:p>
+          <a:p>
+            <a:r>
+              <a:t>💡 İnfografik: Ev ağı kurulumu diyagramı</a:t>
+            </a:r>
+          </a:p>
+          <a:p>
+            <a:r>
+              <a:t>📸 Görsel: Farklı grafik türleri örnekleri</a:t>
+            </a:r>
+          </a:p>
+          <a:p>
+            <a:r>
+              <a:t>🎬 Video: Veri görselleştirme önemi</a:t>
+            </a:r>
+          </a:p>
+          <a:p>
+            <a:r>
+              <a:t>💡 İnfografik: Grafik türleri ve kullanım alanları</a:t>
+            </a:r>
+          </a:p>
+          <a:p>
+            <a:r>
+              <a:t>📸 Görsel: Dijital çağ görselleri ve teknoloji örnekleri</a:t>
+            </a:r>
+          </a:p>
+          <a:p>
+            <a:r>
+              <a:t>🎬 Video: Bilişim teknolojilerinin tarihçesi</a:t>
+            </a:r>
+          </a:p>
         </p:txBody>
       </p:sp>
       <p:sp>
@@ -873,6 +1950,98 @@
               <a:t>Görseller: Her kategori için örnek resimler ekleyin</a:t>
             </a:r>
           </a:p>
+          <a:p/>
+          <a:p>
+            <a:r>
+              <a:t>🎨 GÖRSELLEŞTİRME ÖNERİLERİ:</a:t>
+            </a:r>
+          </a:p>
+          <a:p/>
+          <a:p>
+            <a:r>
+              <a:t>📸 Görsel: CPU, RAM ve anakart fotoğrafları</a:t>
+            </a:r>
+          </a:p>
+          <a:p>
+            <a:r>
+              <a:t>🎬 Video: Bilgisayar donanımı tanıtım videosu (1-2 dk)</a:t>
+            </a:r>
+          </a:p>
+          <a:p>
+            <a:r>
+              <a:t>💡 İnfografik: Bilgisayar bileşenleri şeması</a:t>
+            </a:r>
+          </a:p>
+          <a:p>
+            <a:r>
+              <a:t>📸 Görsel: HDD vs SSD karşılaştırması</a:t>
+            </a:r>
+          </a:p>
+          <a:p>
+            <a:r>
+              <a:t>🎬 Video: Depolama birimleri animasyonu</a:t>
+            </a:r>
+          </a:p>
+          <a:p>
+            <a:r>
+              <a:t>💡 İnfografik: Depolama kapasiteleri karşılaştırma tablosu</a:t>
+            </a:r>
+          </a:p>
+          <a:p>
+            <a:r>
+              <a:t>📸 Görsel: LAN ve WAN ağ topolojileri şeması</a:t>
+            </a:r>
+          </a:p>
+          <a:p>
+            <a:r>
+              <a:t>🎬 Video: İnternet nasıl çalışır? Animasyonlu anlatım</a:t>
+            </a:r>
+          </a:p>
+          <a:p>
+            <a:r>
+              <a:t>💡 İnfografik: Ev ağı kurulumu diyagramı</a:t>
+            </a:r>
+          </a:p>
+          <a:p>
+            <a:r>
+              <a:t>📸 Görsel: Scratch arayüzü ekran görüntüsü</a:t>
+            </a:r>
+          </a:p>
+          <a:p>
+            <a:r>
+              <a:t>🎬 Video: Scratch ile basit oyun yapımı (3-5 dk)</a:t>
+            </a:r>
+          </a:p>
+          <a:p>
+            <a:r>
+              <a:t>💡 Ekran kaydı: Adım adım Scratch projesi</a:t>
+            </a:r>
+          </a:p>
+          <a:p>
+            <a:r>
+              <a:t>📸 Görsel: Farklı grafik türleri örnekleri</a:t>
+            </a:r>
+          </a:p>
+          <a:p>
+            <a:r>
+              <a:t>🎬 Video: Veri görselleştirme önemi</a:t>
+            </a:r>
+          </a:p>
+          <a:p>
+            <a:r>
+              <a:t>💡 İnfografik: Grafik türleri ve kullanım alanları</a:t>
+            </a:r>
+          </a:p>
+          <a:p>
+            <a:r>
+              <a:t>📸 Görsel: Dijital çağ görselleri ve teknoloji örnekleri</a:t>
+            </a:r>
+          </a:p>
+          <a:p>
+            <a:r>
+              <a:t>🎬 Video: Bilişim teknolojilerinin tarihçesi</a:t>
+            </a:r>
+          </a:p>
         </p:txBody>
       </p:sp>
       <p:sp>
@@ -943,6 +2112,78 @@
               <a:t>Görseller: Donanım ve yazılım karşılaştırma görselleri</a:t>
             </a:r>
           </a:p>
+          <a:p/>
+          <a:p>
+            <a:r>
+              <a:t>🎨 GÖRSELLEŞTİRME ÖNERİLERİ:</a:t>
+            </a:r>
+          </a:p>
+          <a:p/>
+          <a:p>
+            <a:r>
+              <a:t>📸 Görsel: CPU, RAM ve anakart fotoğrafları</a:t>
+            </a:r>
+          </a:p>
+          <a:p>
+            <a:r>
+              <a:t>🎬 Video: Bilgisayar donanımı tanıtım videosu (1-2 dk)</a:t>
+            </a:r>
+          </a:p>
+          <a:p>
+            <a:r>
+              <a:t>💡 İnfografik: Bilgisayar bileşenleri şeması</a:t>
+            </a:r>
+          </a:p>
+          <a:p>
+            <a:r>
+              <a:t>📸 Görsel: Çeşitli giriş aygıtları (klavye, fare, mikrofon, kamera)</a:t>
+            </a:r>
+          </a:p>
+          <a:p>
+            <a:r>
+              <a:t>🎬 Video: Giriş aygıtlarının nasıl çalıştığını gösteren animasyon</a:t>
+            </a:r>
+          </a:p>
+          <a:p>
+            <a:r>
+              <a:t>📸 Görsel: Farklı işletim sistemleri logoları ve ekran görüntüleri</a:t>
+            </a:r>
+          </a:p>
+          <a:p>
+            <a:r>
+              <a:t>🎬 Video: İşletim sistemi nedir? Animasyonlu anlatım</a:t>
+            </a:r>
+          </a:p>
+          <a:p>
+            <a:r>
+              <a:t>📸 Görsel: MS Word arayüz ekran görüntüsü</a:t>
+            </a:r>
+          </a:p>
+          <a:p>
+            <a:r>
+              <a:t>🎬 Video: Word temel özellikleri demo (2-3 dk)</a:t>
+            </a:r>
+          </a:p>
+          <a:p>
+            <a:r>
+              <a:t>💡 Ekran kaydı: Biçimlendirme araçları kullanımı</a:t>
+            </a:r>
+          </a:p>
+          <a:p>
+            <a:r>
+              <a:t>📸 Görsel: Scratch arayüzü ekran görüntüsü</a:t>
+            </a:r>
+          </a:p>
+          <a:p>
+            <a:r>
+              <a:t>🎬 Video: Scratch ile basit oyun yapımı (3-5 dk)</a:t>
+            </a:r>
+          </a:p>
+          <a:p>
+            <a:r>
+              <a:t>💡 Ekran kaydı: Adım adım Scratch projesi</a:t>
+            </a:r>
+          </a:p>
         </p:txBody>
       </p:sp>
       <p:sp>
@@ -1013,6 +2254,43 @@
               <a:t>Video: 'CPU Nasıl Çalışır?' animasyonu izletin</a:t>
             </a:r>
           </a:p>
+          <a:p/>
+          <a:p>
+            <a:r>
+              <a:t>🎨 GÖRSELLEŞTİRME ÖNERİLERİ:</a:t>
+            </a:r>
+          </a:p>
+          <a:p/>
+          <a:p>
+            <a:r>
+              <a:t>📸 Görsel: CPU, RAM ve anakart fotoğrafları</a:t>
+            </a:r>
+          </a:p>
+          <a:p>
+            <a:r>
+              <a:t>🎬 Video: Bilgisayar donanımı tanıtım videosu (1-2 dk)</a:t>
+            </a:r>
+          </a:p>
+          <a:p>
+            <a:r>
+              <a:t>💡 İnfografik: Bilgisayar bileşenleri şeması</a:t>
+            </a:r>
+          </a:p>
+          <a:p>
+            <a:r>
+              <a:t>📸 Görsel: Farklı grafik türleri örnekleri</a:t>
+            </a:r>
+          </a:p>
+          <a:p>
+            <a:r>
+              <a:t>🎬 Video: Veri görselleştirme önemi</a:t>
+            </a:r>
+          </a:p>
+          <a:p>
+            <a:r>
+              <a:t>💡 İnfografik: Grafik türleri ve kullanım alanları</a:t>
+            </a:r>
+          </a:p>
         </p:txBody>
       </p:sp>
       <p:sp>
@@ -1083,6 +2361,88 @@
               <a:t>Görseller: RAM kartı fotoğrafı ve çalışma masası analojisi</a:t>
             </a:r>
           </a:p>
+          <a:p/>
+          <a:p>
+            <a:r>
+              <a:t>🎨 GÖRSELLEŞTİRME ÖNERİLERİ:</a:t>
+            </a:r>
+          </a:p>
+          <a:p/>
+          <a:p>
+            <a:r>
+              <a:t>📸 Görsel: CPU, RAM ve anakart fotoğrafları</a:t>
+            </a:r>
+          </a:p>
+          <a:p>
+            <a:r>
+              <a:t>🎬 Video: Bilgisayar donanımı tanıtım videosu (1-2 dk)</a:t>
+            </a:r>
+          </a:p>
+          <a:p>
+            <a:r>
+              <a:t>💡 İnfografik: Bilgisayar bileşenleri şeması</a:t>
+            </a:r>
+          </a:p>
+          <a:p>
+            <a:r>
+              <a:t>📸 Görsel: LAN ve WAN ağ topolojileri şeması</a:t>
+            </a:r>
+          </a:p>
+          <a:p>
+            <a:r>
+              <a:t>🎬 Video: İnternet nasıl çalışır? Animasyonlu anlatım</a:t>
+            </a:r>
+          </a:p>
+          <a:p>
+            <a:r>
+              <a:t>💡 İnfografik: Ev ağı kurulumu diyagramı</a:t>
+            </a:r>
+          </a:p>
+          <a:p>
+            <a:r>
+              <a:t>📸 Görsel: Scratch arayüzü ekran görüntüsü</a:t>
+            </a:r>
+          </a:p>
+          <a:p>
+            <a:r>
+              <a:t>🎬 Video: Scratch ile basit oyun yapımı (3-5 dk)</a:t>
+            </a:r>
+          </a:p>
+          <a:p>
+            <a:r>
+              <a:t>💡 Ekran kaydı: Adım adım Scratch projesi</a:t>
+            </a:r>
+          </a:p>
+          <a:p>
+            <a:r>
+              <a:t>📸 Görsel: Farklı grafik türleri örnekleri</a:t>
+            </a:r>
+          </a:p>
+          <a:p>
+            <a:r>
+              <a:t>🎬 Video: Veri görselleştirme önemi</a:t>
+            </a:r>
+          </a:p>
+          <a:p>
+            <a:r>
+              <a:t>💡 İnfografik: Grafik türleri ve kullanım alanları</a:t>
+            </a:r>
+          </a:p>
+          <a:p>
+            <a:r>
+              <a:t>📸 Görsel: Temel tasarım prensipleri</a:t>
+            </a:r>
+          </a:p>
+          <a:p>
+            <a:r>
+              <a:t>🎬 Video: Dijital tasarıma giriş</a:t>
+            </a:r>
+          </a:p>
+          <a:p>
+            <a:r>
+              <a:t>💡 İnfografik: Renk teorisi ve uyumu</a:t>
+            </a:r>
+          </a:p>
         </p:txBody>
       </p:sp>
       <p:sp>
@@ -1153,6 +2513,58 @@
               <a:t>Video: 'HDD vs SSD Karşılaştırması' izletin</a:t>
             </a:r>
           </a:p>
+          <a:p/>
+          <a:p>
+            <a:r>
+              <a:t>🎨 GÖRSELLEŞTİRME ÖNERİLERİ:</a:t>
+            </a:r>
+          </a:p>
+          <a:p/>
+          <a:p>
+            <a:r>
+              <a:t>📸 Görsel: CPU, RAM ve anakart fotoğrafları</a:t>
+            </a:r>
+          </a:p>
+          <a:p>
+            <a:r>
+              <a:t>🎬 Video: Bilgisayar donanımı tanıtım videosu (1-2 dk)</a:t>
+            </a:r>
+          </a:p>
+          <a:p>
+            <a:r>
+              <a:t>💡 İnfografik: Bilgisayar bileşenleri şeması</a:t>
+            </a:r>
+          </a:p>
+          <a:p>
+            <a:r>
+              <a:t>📸 Görsel: HDD vs SSD karşılaştırması</a:t>
+            </a:r>
+          </a:p>
+          <a:p>
+            <a:r>
+              <a:t>🎬 Video: Depolama birimleri animasyonu</a:t>
+            </a:r>
+          </a:p>
+          <a:p>
+            <a:r>
+              <a:t>💡 İnfografik: Depolama kapasiteleri karşılaştırma tablosu</a:t>
+            </a:r>
+          </a:p>
+          <a:p>
+            <a:r>
+              <a:t>📸 Görsel: Farklı grafik türleri örnekleri</a:t>
+            </a:r>
+          </a:p>
+          <a:p>
+            <a:r>
+              <a:t>🎬 Video: Veri görselleştirme önemi</a:t>
+            </a:r>
+          </a:p>
+          <a:p>
+            <a:r>
+              <a:t>💡 İnfografik: Grafik türleri ve kullanım alanları</a:t>
+            </a:r>
+          </a:p>
         </p:txBody>
       </p:sp>
       <p:sp>
@@ -1223,6 +2635,58 @@
               <a:t>Görseller: Anakart fotoğrafı ve etiketli diyagram</a:t>
             </a:r>
           </a:p>
+          <a:p/>
+          <a:p>
+            <a:r>
+              <a:t>🎨 GÖRSELLEŞTİRME ÖNERİLERİ:</a:t>
+            </a:r>
+          </a:p>
+          <a:p/>
+          <a:p>
+            <a:r>
+              <a:t>📸 Görsel: CPU, RAM ve anakart fotoğrafları</a:t>
+            </a:r>
+          </a:p>
+          <a:p>
+            <a:r>
+              <a:t>🎬 Video: Bilgisayar donanımı tanıtım videosu (1-2 dk)</a:t>
+            </a:r>
+          </a:p>
+          <a:p>
+            <a:r>
+              <a:t>💡 İnfografik: Bilgisayar bileşenleri şeması</a:t>
+            </a:r>
+          </a:p>
+          <a:p>
+            <a:r>
+              <a:t>📸 Görsel: HDD vs SSD karşılaştırması</a:t>
+            </a:r>
+          </a:p>
+          <a:p>
+            <a:r>
+              <a:t>🎬 Video: Depolama birimleri animasyonu</a:t>
+            </a:r>
+          </a:p>
+          <a:p>
+            <a:r>
+              <a:t>💡 İnfografik: Depolama kapasiteleri karşılaştırma tablosu</a:t>
+            </a:r>
+          </a:p>
+          <a:p>
+            <a:r>
+              <a:t>📸 Görsel: LAN ve WAN ağ topolojileri şeması</a:t>
+            </a:r>
+          </a:p>
+          <a:p>
+            <a:r>
+              <a:t>🎬 Video: İnternet nasıl çalışır? Animasyonlu anlatım</a:t>
+            </a:r>
+          </a:p>
+          <a:p>
+            <a:r>
+              <a:t>💡 İnfografik: Ev ağı kurulumu diyagramı</a:t>
+            </a:r>
+          </a:p>
         </p:txBody>
       </p:sp>
       <p:sp>
@@ -1291,6 +2755,68 @@
           <a:p>
             <a:r>
               <a:t>Video: 'İşletim Sistemleri Tanıtımı'</a:t>
+            </a:r>
+          </a:p>
+          <a:p/>
+          <a:p>
+            <a:r>
+              <a:t>🎨 GÖRSELLEŞTİRME ÖNERİLERİ:</a:t>
+            </a:r>
+          </a:p>
+          <a:p/>
+          <a:p>
+            <a:r>
+              <a:t>📸 Görsel: CPU, RAM ve anakart fotoğrafları</a:t>
+            </a:r>
+          </a:p>
+          <a:p>
+            <a:r>
+              <a:t>🎬 Video: Bilgisayar donanımı tanıtım videosu (1-2 dk)</a:t>
+            </a:r>
+          </a:p>
+          <a:p>
+            <a:r>
+              <a:t>💡 İnfografik: Bilgisayar bileşenleri şeması</a:t>
+            </a:r>
+          </a:p>
+          <a:p>
+            <a:r>
+              <a:t>📸 Görsel: Farklı işletim sistemleri logoları ve ekran görüntüleri</a:t>
+            </a:r>
+          </a:p>
+          <a:p>
+            <a:r>
+              <a:t>🎬 Video: İşletim sistemi nedir? Animasyonlu anlatım</a:t>
+            </a:r>
+          </a:p>
+          <a:p>
+            <a:r>
+              <a:t>📸 Görsel: LAN ve WAN ağ topolojileri şeması</a:t>
+            </a:r>
+          </a:p>
+          <a:p>
+            <a:r>
+              <a:t>🎬 Video: İnternet nasıl çalışır? Animasyonlu anlatım</a:t>
+            </a:r>
+          </a:p>
+          <a:p>
+            <a:r>
+              <a:t>💡 İnfografik: Ev ağı kurulumu diyagramı</a:t>
+            </a:r>
+          </a:p>
+          <a:p>
+            <a:r>
+              <a:t>📸 Görsel: Scratch arayüzü ekran görüntüsü</a:t>
+            </a:r>
+          </a:p>
+          <a:p>
+            <a:r>
+              <a:t>🎬 Video: Scratch ile basit oyun yapımı (3-5 dk)</a:t>
+            </a:r>
+          </a:p>
+          <a:p>
+            <a:r>
+              <a:t>💡 Ekran kaydı: Adım adım Scratch projesi</a:t>
             </a:r>
           </a:p>
         </p:txBody>
@@ -5248,6 +6774,7 @@
               <a:defRPr sz="2000"/>
             </a:pPr>
             <a:r>
+              <a:rPr sz="1600"/>
               <a:t>Microsoft tarafından geliştirilmiş en popüler OS</a:t>
             </a:r>
           </a:p>
@@ -5267,6 +6794,7 @@
               <a:defRPr sz="2000"/>
             </a:pPr>
             <a:r>
+              <a:rPr sz="1600"/>
               <a:t>✅ Önemli Özellikler:</a:t>
             </a:r>
           </a:p>
@@ -5278,6 +6806,7 @@
               <a:defRPr sz="2000"/>
             </a:pPr>
             <a:r>
+              <a:rPr sz="1600"/>
               <a:t>    • Kullanıcı dostu arayüz</a:t>
             </a:r>
           </a:p>
@@ -5289,6 +6818,7 @@
               <a:defRPr sz="2000"/>
             </a:pPr>
             <a:r>
+              <a:rPr sz="1600"/>
               <a:t>    • Başlat menüsü</a:t>
             </a:r>
           </a:p>
@@ -5300,6 +6830,7 @@
               <a:defRPr sz="2000"/>
             </a:pPr>
             <a:r>
+              <a:rPr sz="1600"/>
               <a:t>    • Görev çubuğu</a:t>
             </a:r>
           </a:p>
@@ -5311,6 +6842,7 @@
               <a:defRPr sz="2000"/>
             </a:pPr>
             <a:r>
+              <a:rPr sz="1600"/>
               <a:t>    • Masaüstü (Desktop)</a:t>
             </a:r>
           </a:p>
@@ -5322,6 +6854,7 @@
               <a:defRPr sz="2000"/>
             </a:pPr>
             <a:r>
+              <a:rPr sz="1600"/>
               <a:t>    • Dosya Gezgini (File Explorer)</a:t>
             </a:r>
           </a:p>
@@ -5341,6 +6874,7 @@
               <a:defRPr sz="2000"/>
             </a:pPr>
             <a:r>
+              <a:rPr sz="1600"/>
               <a:t>✅ Sürümler:</a:t>
             </a:r>
           </a:p>
@@ -5352,6 +6886,7 @@
               <a:defRPr sz="2000"/>
             </a:pPr>
             <a:r>
+              <a:rPr sz="1600"/>
               <a:t>    • Windows 10</a:t>
             </a:r>
           </a:p>
@@ -5363,6 +6898,7 @@
               <a:defRPr sz="2000"/>
             </a:pPr>
             <a:r>
+              <a:rPr sz="1600"/>
               <a:t>    • Windows 11 (En yeni)</a:t>
             </a:r>
           </a:p>
@@ -5382,6 +6918,7 @@
               <a:defRPr sz="2000"/>
             </a:pPr>
             <a:r>
+              <a:rPr sz="1600"/>
               <a:t>✅ Temel Kısayollar:</a:t>
             </a:r>
           </a:p>
@@ -5393,6 +6930,7 @@
               <a:defRPr sz="2000"/>
             </a:pPr>
             <a:r>
+              <a:rPr sz="1600"/>
               <a:t>    • Windows tuşu - Başlat menüsü</a:t>
             </a:r>
           </a:p>
@@ -5404,6 +6942,7 @@
               <a:defRPr sz="2000"/>
             </a:pPr>
             <a:r>
+              <a:rPr sz="1600"/>
               <a:t>    • Windows + E - Dosya Gezgini</a:t>
             </a:r>
           </a:p>
@@ -5415,6 +6954,7 @@
               <a:defRPr sz="2000"/>
             </a:pPr>
             <a:r>
+              <a:rPr sz="1600"/>
               <a:t>    • Alt + Tab - Pencereler arası geçiş</a:t>
             </a:r>
           </a:p>
@@ -5426,6 +6966,7 @@
               <a:defRPr sz="2000"/>
             </a:pPr>
             <a:r>
+              <a:rPr sz="1600"/>
               <a:t>    • Ctrl + Alt + Delete - Görev yöneticisi</a:t>
             </a:r>
           </a:p>
@@ -5524,6 +7065,7 @@
               <a:defRPr sz="2000"/>
             </a:pPr>
             <a:r>
+              <a:rPr sz="1600"/>
               <a:t>📄 DOSYA (File):</a:t>
             </a:r>
           </a:p>
@@ -5535,6 +7077,7 @@
               <a:defRPr sz="2000"/>
             </a:pPr>
             <a:r>
+              <a:rPr sz="1600"/>
               <a:t>    • Bilgisayarda saklanan her türlü bilgi</a:t>
             </a:r>
           </a:p>
@@ -5546,6 +7089,7 @@
               <a:defRPr sz="2000"/>
             </a:pPr>
             <a:r>
+              <a:rPr sz="1600"/>
               <a:t>    • Örnekler: Resim, video, müzik, belge</a:t>
             </a:r>
           </a:p>
@@ -5565,6 +7109,7 @@
               <a:defRPr sz="2000"/>
             </a:pPr>
             <a:r>
+              <a:rPr sz="1600"/>
               <a:t>📁 KLASÖR (Folder):</a:t>
             </a:r>
           </a:p>
@@ -5576,6 +7121,7 @@
               <a:defRPr sz="2000"/>
             </a:pPr>
             <a:r>
+              <a:rPr sz="1600"/>
               <a:t>    • Dosyaları düzenli tutmak için sanal çekmece</a:t>
             </a:r>
           </a:p>
@@ -5587,6 +7133,7 @@
               <a:defRPr sz="2000"/>
             </a:pPr>
             <a:r>
+              <a:rPr sz="1600"/>
               <a:t>    • İçinde dosya ve alt klasörler olabilir</a:t>
             </a:r>
           </a:p>
@@ -5606,6 +7153,7 @@
               <a:defRPr sz="2000"/>
             </a:pPr>
             <a:r>
+              <a:rPr sz="1600"/>
               <a:t>✅ Dosya Uzantıları:</a:t>
             </a:r>
           </a:p>
@@ -5617,6 +7165,7 @@
               <a:defRPr sz="2000"/>
             </a:pPr>
             <a:r>
+              <a:rPr sz="1600"/>
               <a:t>    • .docx - Word belgesi</a:t>
             </a:r>
           </a:p>
@@ -5628,6 +7177,7 @@
               <a:defRPr sz="2000"/>
             </a:pPr>
             <a:r>
+              <a:rPr sz="1600"/>
               <a:t>    • .xlsx - Excel tablosu</a:t>
             </a:r>
           </a:p>
@@ -5639,6 +7189,7 @@
               <a:defRPr sz="2000"/>
             </a:pPr>
             <a:r>
+              <a:rPr sz="1600"/>
               <a:t>    • .pptx - PowerPoint sunumu</a:t>
             </a:r>
           </a:p>
@@ -5650,6 +7201,7 @@
               <a:defRPr sz="2000"/>
             </a:pPr>
             <a:r>
+              <a:rPr sz="1600"/>
               <a:t>    • .jpg, .png - Resim</a:t>
             </a:r>
           </a:p>
@@ -5661,6 +7213,7 @@
               <a:defRPr sz="2000"/>
             </a:pPr>
             <a:r>
+              <a:rPr sz="1600"/>
               <a:t>    • .mp4, .avi - Video</a:t>
             </a:r>
           </a:p>
@@ -5672,6 +7225,7 @@
               <a:defRPr sz="2000"/>
             </a:pPr>
             <a:r>
+              <a:rPr sz="1600"/>
               <a:t>    • .mp3 - Müzik</a:t>
             </a:r>
           </a:p>
@@ -5683,6 +7237,7 @@
               <a:defRPr sz="2000"/>
             </a:pPr>
             <a:r>
+              <a:rPr sz="1600"/>
               <a:t>    • .pdf - PDF belgesi</a:t>
             </a:r>
           </a:p>
@@ -5694,6 +7249,7 @@
               <a:defRPr sz="2000"/>
             </a:pPr>
             <a:r>
+              <a:rPr sz="1600"/>
               <a:t>    • .exe - Program dosyası</a:t>
             </a:r>
           </a:p>
@@ -6081,6 +7637,7 @@
               <a:defRPr sz="2000"/>
             </a:pPr>
             <a:r>
+              <a:rPr sz="1600"/>
               <a:t>✅ Anlamlı İsimler Kullanın:</a:t>
             </a:r>
           </a:p>
@@ -6092,6 +7649,7 @@
               <a:defRPr sz="2000"/>
             </a:pPr>
             <a:r>
+              <a:rPr sz="1600"/>
               <a:t>    ❌ Yanlış: Belge1.docx, 12345.jpg</a:t>
             </a:r>
           </a:p>
@@ -6103,6 +7661,7 @@
               <a:defRPr sz="2000"/>
             </a:pPr>
             <a:r>
+              <a:rPr sz="1600"/>
               <a:t>    ✅ Doğru: Matematik_Odevi.docx, Aile_Tatili_2025.jpg</a:t>
             </a:r>
           </a:p>
@@ -6122,6 +7681,7 @@
               <a:defRPr sz="2000"/>
             </a:pPr>
             <a:r>
+              <a:rPr sz="1600"/>
               <a:t>✅ Klasör Yapısı Oluşturun:</a:t>
             </a:r>
           </a:p>
@@ -6133,6 +7693,7 @@
               <a:defRPr sz="2000"/>
             </a:pPr>
             <a:r>
+              <a:rPr sz="1600"/>
               <a:t>    📁 Belgeler</a:t>
             </a:r>
           </a:p>
@@ -6144,6 +7705,7 @@
               <a:defRPr sz="2000"/>
             </a:pPr>
             <a:r>
+              <a:rPr sz="1600"/>
               <a:t>        📁 Okulİşleri</a:t>
             </a:r>
           </a:p>
@@ -6155,6 +7717,7 @@
               <a:defRPr sz="2000"/>
             </a:pPr>
             <a:r>
+              <a:rPr sz="1600"/>
               <a:t>            📁 Matematik</a:t>
             </a:r>
           </a:p>
@@ -6166,6 +7729,7 @@
               <a:defRPr sz="2000"/>
             </a:pPr>
             <a:r>
+              <a:rPr sz="1600"/>
               <a:t>            📁 Türkçe</a:t>
             </a:r>
           </a:p>
@@ -6177,6 +7741,7 @@
               <a:defRPr sz="2000"/>
             </a:pPr>
             <a:r>
+              <a:rPr sz="1600"/>
               <a:t>        📁 Kişisel</a:t>
             </a:r>
           </a:p>
@@ -6196,6 +7761,7 @@
               <a:defRPr sz="2000"/>
             </a:pPr>
             <a:r>
+              <a:rPr sz="1600"/>
               <a:t>✅ Düzenli Yedekleme:</a:t>
             </a:r>
           </a:p>
@@ -6207,6 +7773,7 @@
               <a:defRPr sz="2000"/>
             </a:pPr>
             <a:r>
+              <a:rPr sz="1600"/>
               <a:t>    • Önemli dosyaları USB veya buluta yedekleyin</a:t>
             </a:r>
           </a:p>
@@ -6218,6 +7785,7 @@
               <a:defRPr sz="2000"/>
             </a:pPr>
             <a:r>
+              <a:rPr sz="1600"/>
               <a:t>    • Haftalık yedekleme alışkanlığı</a:t>
             </a:r>
           </a:p>
@@ -6237,6 +7805,7 @@
               <a:defRPr sz="2000"/>
             </a:pPr>
             <a:r>
+              <a:rPr sz="1600"/>
               <a:t>✅ Gereksizleri Silin:</a:t>
             </a:r>
           </a:p>
@@ -6248,6 +7817,7 @@
               <a:defRPr sz="2000"/>
             </a:pPr>
             <a:r>
+              <a:rPr sz="1600"/>
               <a:t>    • İndirilenler klasörünü temizleyin</a:t>
             </a:r>
           </a:p>
@@ -6259,6 +7829,7 @@
               <a:defRPr sz="2000"/>
             </a:pPr>
             <a:r>
+              <a:rPr sz="1600"/>
               <a:t>    • Eski dosyaları arşivleyin</a:t>
             </a:r>
           </a:p>
@@ -6357,6 +7928,7 @@
               <a:defRPr sz="2000"/>
             </a:pPr>
             <a:r>
+              <a:rPr sz="1600"/>
               <a:t>Bu ünitede öğrendiklerimiz:</a:t>
             </a:r>
           </a:p>
@@ -6376,6 +7948,7 @@
               <a:defRPr sz="2000"/>
             </a:pPr>
             <a:r>
+              <a:rPr sz="1600"/>
               <a:t>✅ Bilişim teknolojilerinin sınıflandırılması</a:t>
             </a:r>
           </a:p>
@@ -6387,6 +7960,7 @@
               <a:defRPr sz="2000"/>
             </a:pPr>
             <a:r>
+              <a:rPr sz="1600"/>
               <a:t>✅ Bilgisayar bileşenleri:</a:t>
             </a:r>
           </a:p>
@@ -6398,6 +7972,7 @@
               <a:defRPr sz="2000"/>
             </a:pPr>
             <a:r>
+              <a:rPr sz="1600"/>
               <a:t>    • İşlemci (CPU) - Beyin</a:t>
             </a:r>
           </a:p>
@@ -6409,6 +7984,7 @@
               <a:defRPr sz="2000"/>
             </a:pPr>
             <a:r>
+              <a:rPr sz="1600"/>
               <a:t>    • RAM - Geçici hafıza</a:t>
             </a:r>
           </a:p>
@@ -6420,6 +7996,7 @@
               <a:defRPr sz="2000"/>
             </a:pPr>
             <a:r>
+              <a:rPr sz="1600"/>
               <a:t>    • Hard Disk/SSD - Kalıcı hafıza</a:t>
             </a:r>
           </a:p>
@@ -6431,6 +8008,7 @@
               <a:defRPr sz="2000"/>
             </a:pPr>
             <a:r>
+              <a:rPr sz="1600"/>
               <a:t>    • Anakart - Bağlantı merkezi</a:t>
             </a:r>
           </a:p>
@@ -6442,6 +8020,7 @@
               <a:defRPr sz="2000"/>
             </a:pPr>
             <a:r>
+              <a:rPr sz="1600"/>
               <a:t>✅ İşletim sistemleri (Windows, Linux, macOS)</a:t>
             </a:r>
           </a:p>
@@ -6453,6 +8032,7 @@
               <a:defRPr sz="2000"/>
             </a:pPr>
             <a:r>
+              <a:rPr sz="1600"/>
               <a:t>✅ Dosya ve klasör yönetimi</a:t>
             </a:r>
           </a:p>
@@ -6464,6 +8044,7 @@
               <a:defRPr sz="2000"/>
             </a:pPr>
             <a:r>
+              <a:rPr sz="1600"/>
               <a:t>✅ Dosya uzantıları ve türleri</a:t>
             </a:r>
           </a:p>
@@ -6475,6 +8056,7 @@
               <a:defRPr sz="2000"/>
             </a:pPr>
             <a:r>
+              <a:rPr sz="1600"/>
               <a:t>✅ İyi düzenleme alışkanlıkları</a:t>
             </a:r>
           </a:p>
@@ -6494,6 +8076,7 @@
               <a:defRPr sz="2000"/>
             </a:pPr>
             <a:r>
+              <a:rPr sz="1600"/>
               <a:t>💡 Unutmayın:</a:t>
             </a:r>
           </a:p>
@@ -6505,6 +8088,7 @@
               <a:defRPr sz="2000"/>
             </a:pPr>
             <a:r>
+              <a:rPr sz="1600"/>
               <a:t>Teknoloji hayatımızı kolaylaştırır,</a:t>
             </a:r>
           </a:p>
@@ -6516,6 +8100,7 @@
               <a:defRPr sz="2000"/>
             </a:pPr>
             <a:r>
+              <a:rPr sz="1600"/>
               <a:t>ama sorumlu kullanılmalıdır!</a:t>
             </a:r>
           </a:p>
@@ -6614,6 +8199,7 @@
               <a:defRPr sz="2000"/>
             </a:pPr>
             <a:r>
+              <a:rPr sz="1600"/>
               <a:t>📺 İzlemeniz Gereken Videolar:</a:t>
             </a:r>
           </a:p>
@@ -6625,6 +8211,7 @@
               <a:defRPr sz="2000"/>
             </a:pPr>
             <a:r>
+              <a:rPr sz="1600"/>
               <a:t>    • 'Bilgisayar Nasıl Çalışır?' (YouTube)</a:t>
             </a:r>
           </a:p>
@@ -6636,6 +8223,7 @@
               <a:defRPr sz="2000"/>
             </a:pPr>
             <a:r>
+              <a:rPr sz="1600"/>
               <a:t>    • 'CPU Animasyonu' (YouTube)</a:t>
             </a:r>
           </a:p>
@@ -6647,6 +8235,7 @@
               <a:defRPr sz="2000"/>
             </a:pPr>
             <a:r>
+              <a:rPr sz="1600"/>
               <a:t>    • 'HDD vs SSD Karşılaştırması' (YouTube)</a:t>
             </a:r>
           </a:p>
@@ -6658,6 +8247,7 @@
               <a:defRPr sz="2000"/>
             </a:pPr>
             <a:r>
+              <a:rPr sz="1600"/>
               <a:t>    • 'İşletim Sistemleri Nedir?' (YouTube)</a:t>
             </a:r>
           </a:p>
@@ -6677,6 +8267,7 @@
               <a:defRPr sz="2000"/>
             </a:pPr>
             <a:r>
+              <a:rPr sz="1600"/>
               <a:t>🌐 Faydalı Web Siteleri:</a:t>
             </a:r>
           </a:p>
@@ -6688,6 +8279,7 @@
               <a:defRPr sz="2000"/>
             </a:pPr>
             <a:r>
+              <a:rPr sz="1600"/>
               <a:t>    • code.org - Programlama öğren</a:t>
             </a:r>
           </a:p>
@@ -6699,6 +8291,7 @@
               <a:defRPr sz="2000"/>
             </a:pPr>
             <a:r>
+              <a:rPr sz="1600"/>
               <a:t>    • scratch.mit.edu - Blok programlama</a:t>
             </a:r>
           </a:p>
@@ -6710,6 +8303,7 @@
               <a:defRPr sz="2000"/>
             </a:pPr>
             <a:r>
+              <a:rPr sz="1600"/>
               <a:t>    • khanacademy.org/tr - Ücretsiz eğitim</a:t>
             </a:r>
           </a:p>
@@ -6729,6 +8323,7 @@
               <a:defRPr sz="2000"/>
             </a:pPr>
             <a:r>
+              <a:rPr sz="1600"/>
               <a:t>📚 Okuma Kaynakları:</a:t>
             </a:r>
           </a:p>
@@ -6740,6 +8335,7 @@
               <a:defRPr sz="2000"/>
             </a:pPr>
             <a:r>
+              <a:rPr sz="1600"/>
               <a:t>    • MEB Ders Kitabı</a:t>
             </a:r>
           </a:p>
@@ -6751,6 +8347,7 @@
               <a:defRPr sz="2000"/>
             </a:pPr>
             <a:r>
+              <a:rPr sz="1600"/>
               <a:t>    • EBA (Eğitim Bilişim Ağı)</a:t>
             </a:r>
           </a:p>
@@ -6770,6 +8367,7 @@
               <a:defRPr sz="2000"/>
             </a:pPr>
             <a:r>
+              <a:rPr sz="1600"/>
               <a:t>❓ Sorularınız için:</a:t>
             </a:r>
           </a:p>
@@ -6781,6 +8379,7 @@
               <a:defRPr sz="2000"/>
             </a:pPr>
             <a:r>
+              <a:rPr sz="1600"/>
               <a:t>    • Öğretmeninizle iletişime geçin!</a:t>
             </a:r>
           </a:p>
@@ -6975,6 +8574,7 @@
               <a:defRPr sz="2000"/>
             </a:pPr>
             <a:r>
+              <a:rPr sz="1600"/>
               <a:t>🖥️ 1. Bilişim Teknolojilerinin Hayatımızdaki Yeri</a:t>
             </a:r>
           </a:p>
@@ -6986,6 +8586,7 @@
               <a:defRPr sz="2000"/>
             </a:pPr>
             <a:r>
+              <a:rPr sz="1600"/>
               <a:t>    • Bilişim Teknolojilerinin Sınıflandırılması</a:t>
             </a:r>
           </a:p>
@@ -6997,6 +8598,7 @@
               <a:defRPr sz="2000"/>
             </a:pPr>
             <a:r>
+              <a:rPr sz="1600"/>
               <a:t>    • Etkileri ve Dijital Sağlık</a:t>
             </a:r>
           </a:p>
@@ -7016,6 +8618,7 @@
               <a:defRPr sz="2000"/>
             </a:pPr>
             <a:r>
+              <a:rPr sz="1600"/>
               <a:t>💻 2. Bilgisayar Sistemleri</a:t>
             </a:r>
           </a:p>
@@ -7027,6 +8630,7 @@
               <a:defRPr sz="2000"/>
             </a:pPr>
             <a:r>
+              <a:rPr sz="1600"/>
               <a:t>    • Donanım Bileşenleri (CPU, RAM, Hard Disk, Anakart)</a:t>
             </a:r>
           </a:p>
@@ -7038,6 +8642,7 @@
               <a:defRPr sz="2000"/>
             </a:pPr>
             <a:r>
+              <a:rPr sz="1600"/>
               <a:t>    • Giriş ve Çıkış Birimleri</a:t>
             </a:r>
           </a:p>
@@ -7057,6 +8662,7 @@
               <a:defRPr sz="2000"/>
             </a:pPr>
             <a:r>
+              <a:rPr sz="1600"/>
               <a:t>⚙️ 3. İşletim Sistemleri</a:t>
             </a:r>
           </a:p>
@@ -7068,6 +8674,7 @@
               <a:defRPr sz="2000"/>
             </a:pPr>
             <a:r>
+              <a:rPr sz="1600"/>
               <a:t>    • Windows, Linux, macOS</a:t>
             </a:r>
           </a:p>
@@ -7079,6 +8686,7 @@
               <a:defRPr sz="2000"/>
             </a:pPr>
             <a:r>
+              <a:rPr sz="1600"/>
               <a:t>    • Temel Görevler ve Kullanım</a:t>
             </a:r>
           </a:p>
@@ -7098,6 +8706,7 @@
               <a:defRPr sz="2000"/>
             </a:pPr>
             <a:r>
+              <a:rPr sz="1600"/>
               <a:t>📁 4. Dosya ve Klasör Yönetimi</a:t>
             </a:r>
           </a:p>
@@ -7109,6 +8718,7 @@
               <a:defRPr sz="2000"/>
             </a:pPr>
             <a:r>
+              <a:rPr sz="1600"/>
               <a:t>    • Dosya Uzantıları</a:t>
             </a:r>
           </a:p>
@@ -7120,6 +8730,7 @@
               <a:defRPr sz="2000"/>
             </a:pPr>
             <a:r>
+              <a:rPr sz="1600"/>
               <a:t>    • Düzenleme ve Yönetim İşlemleri</a:t>
             </a:r>
           </a:p>
@@ -8207,6 +9818,7 @@
               <a:defRPr sz="2000"/>
             </a:pPr>
             <a:r>
+              <a:rPr sz="1600"/>
               <a:t>CPU = Central Processing Unit (Merkezi İşlem Birimi)</a:t>
             </a:r>
           </a:p>
@@ -8226,6 +9838,7 @@
               <a:defRPr sz="2000"/>
             </a:pPr>
             <a:r>
+              <a:rPr sz="1600"/>
               <a:t>✅ Görevleri:</a:t>
             </a:r>
           </a:p>
@@ -8237,6 +9850,7 @@
               <a:defRPr sz="2000"/>
             </a:pPr>
             <a:r>
+              <a:rPr sz="1600"/>
               <a:t>    • Tüm hesaplamaları yapar</a:t>
             </a:r>
           </a:p>
@@ -8248,6 +9862,7 @@
               <a:defRPr sz="2000"/>
             </a:pPr>
             <a:r>
+              <a:rPr sz="1600"/>
               <a:t>    • Komutları işler</a:t>
             </a:r>
           </a:p>
@@ -8259,6 +9874,7 @@
               <a:defRPr sz="2000"/>
             </a:pPr>
             <a:r>
+              <a:rPr sz="1600"/>
               <a:t>    • Verileri işleyip sonuç üretir</a:t>
             </a:r>
           </a:p>
@@ -8278,6 +9894,7 @@
               <a:defRPr sz="2000"/>
             </a:pPr>
             <a:r>
+              <a:rPr sz="1600"/>
               <a:t>✅ Önemli Özellikler:</a:t>
             </a:r>
           </a:p>
@@ -8289,6 +9906,7 @@
               <a:defRPr sz="2000"/>
             </a:pPr>
             <a:r>
+              <a:rPr sz="1600"/>
               <a:t>    • GHz (Gigahertz) - Hız birimi</a:t>
             </a:r>
           </a:p>
@@ -8300,6 +9918,7 @@
               <a:defRPr sz="2000"/>
             </a:pPr>
             <a:r>
+              <a:rPr sz="1600"/>
               <a:t>    • Çekirdek sayısı (2, 4, 8 çekirdek...)</a:t>
             </a:r>
           </a:p>
@@ -8311,6 +9930,7 @@
               <a:defRPr sz="2000"/>
             </a:pPr>
             <a:r>
+              <a:rPr sz="1600"/>
               <a:t>    • Önbellek (Cache)</a:t>
             </a:r>
           </a:p>
@@ -8330,6 +9950,7 @@
               <a:defRPr sz="2000"/>
             </a:pPr>
             <a:r>
+              <a:rPr sz="1600"/>
               <a:t>📌 Popüler Markalar:</a:t>
             </a:r>
           </a:p>
@@ -8341,6 +9962,7 @@
               <a:defRPr sz="2000"/>
             </a:pPr>
             <a:r>
+              <a:rPr sz="1600"/>
               <a:t>Intel (i3, i5, i7, i9) ve AMD (Ryzen)</a:t>
             </a:r>
           </a:p>
@@ -8360,6 +9982,7 @@
               <a:defRPr sz="2000"/>
             </a:pPr>
             <a:r>
+              <a:rPr sz="1600"/>
               <a:t>💡 Analoji: İşlemci = İnsan beyni</a:t>
             </a:r>
           </a:p>
@@ -8371,6 +9994,7 @@
               <a:defRPr sz="2000"/>
             </a:pPr>
             <a:r>
+              <a:rPr sz="1600"/>
               <a:t>Ne kadar hızlı düşünürsen, işleri o kadar çabuk bitirirsin!</a:t>
             </a:r>
           </a:p>
@@ -8469,6 +10093,7 @@
               <a:defRPr sz="2000"/>
             </a:pPr>
             <a:r>
+              <a:rPr sz="1600"/>
               <a:t>RAM = Random Access Memory (Rastgele Erişimli Bellek)</a:t>
             </a:r>
           </a:p>
@@ -8488,6 +10113,7 @@
               <a:defRPr sz="2000"/>
             </a:pPr>
             <a:r>
+              <a:rPr sz="1600"/>
               <a:t>✅ Görevleri:</a:t>
             </a:r>
           </a:p>
@@ -8499,6 +10125,7 @@
               <a:defRPr sz="2000"/>
             </a:pPr>
             <a:r>
+              <a:rPr sz="1600"/>
               <a:t>    • Açık programların verilerini tutar</a:t>
             </a:r>
           </a:p>
@@ -8510,6 +10137,7 @@
               <a:defRPr sz="2000"/>
             </a:pPr>
             <a:r>
+              <a:rPr sz="1600"/>
               <a:t>    • Geçici çalışma alanı sağlar</a:t>
             </a:r>
           </a:p>
@@ -8521,6 +10149,7 @@
               <a:defRPr sz="2000"/>
             </a:pPr>
             <a:r>
+              <a:rPr sz="1600"/>
               <a:t>    • İşlemciye hızlı veri erişimi</a:t>
             </a:r>
           </a:p>
@@ -8540,6 +10169,7 @@
               <a:defRPr sz="2000"/>
             </a:pPr>
             <a:r>
+              <a:rPr sz="1600"/>
               <a:t>⚠️ Önemli Özelliği:</a:t>
             </a:r>
           </a:p>
@@ -8551,6 +10181,7 @@
               <a:defRPr sz="2000"/>
             </a:pPr>
             <a:r>
+              <a:rPr sz="1600"/>
               <a:t>Bilgisayar kapatıldığında içindeki</a:t>
             </a:r>
           </a:p>
@@ -8562,6 +10193,7 @@
               <a:defRPr sz="2000"/>
             </a:pPr>
             <a:r>
+              <a:rPr sz="1600"/>
               <a:t>TÜM VERİLER SİLİNİR!</a:t>
             </a:r>
           </a:p>
@@ -8581,6 +10213,7 @@
               <a:defRPr sz="2000"/>
             </a:pPr>
             <a:r>
+              <a:rPr sz="1600"/>
               <a:t>📊 Kapasiteler:</a:t>
             </a:r>
           </a:p>
@@ -8592,6 +10225,7 @@
               <a:defRPr sz="2000"/>
             </a:pPr>
             <a:r>
+              <a:rPr sz="1600"/>
               <a:t>    • 4 GB - Temel kullanım</a:t>
             </a:r>
           </a:p>
@@ -8603,6 +10237,7 @@
               <a:defRPr sz="2000"/>
             </a:pPr>
             <a:r>
+              <a:rPr sz="1600"/>
               <a:t>    • 8 GB - Günlük kullanım</a:t>
             </a:r>
           </a:p>
@@ -8614,6 +10249,7 @@
               <a:defRPr sz="2000"/>
             </a:pPr>
             <a:r>
+              <a:rPr sz="1600"/>
               <a:t>    • 16 GB+ - Oyun/Tasarım</a:t>
             </a:r>
           </a:p>
@@ -8633,6 +10269,7 @@
               <a:defRPr sz="2000"/>
             </a:pPr>
             <a:r>
+              <a:rPr sz="1600"/>
               <a:t>💡 Analoji: RAM = Çalışma masası</a:t>
             </a:r>
           </a:p>
@@ -8644,6 +10281,7 @@
               <a:defRPr sz="2000"/>
             </a:pPr>
             <a:r>
+              <a:rPr sz="1600"/>
               <a:t>Masası büyük olan daha çok iş yapabilir!</a:t>
             </a:r>
           </a:p>

</xml_diff>